<commit_message>
Add connection to sql server
</commit_message>
<xml_diff>
--- a/etc/recon.pptx
+++ b/etc/recon.pptx
@@ -3059,6 +3059,152 @@
           <a:chExt cx="0" cy="0"/>
         </a:xfrm>
       </p:grpSpPr>
+      <p:sp>
+        <p:nvSpPr>
+          <p:cNvPr id="43" name="Retângulo 42"/>
+          <p:cNvSpPr/>
+          <p:nvPr/>
+        </p:nvSpPr>
+        <p:spPr>
+          <a:xfrm>
+            <a:off x="6248400" y="381000"/>
+            <a:ext cx="2438400" cy="1524000"/>
+          </a:xfrm>
+          <a:prstGeom prst="rect">
+            <a:avLst/>
+          </a:prstGeom>
+          <a:solidFill>
+            <a:schemeClr val="bg1"/>
+          </a:solidFill>
+          <a:ln w="6350">
+            <a:solidFill>
+              <a:schemeClr val="tx1"/>
+            </a:solidFill>
+          </a:ln>
+        </p:spPr>
+        <p:style>
+          <a:lnRef idx="2">
+            <a:schemeClr val="accent1">
+              <a:shade val="50000"/>
+            </a:schemeClr>
+          </a:lnRef>
+          <a:fillRef idx="1">
+            <a:schemeClr val="accent1"/>
+          </a:fillRef>
+          <a:effectRef idx="0">
+            <a:schemeClr val="accent1"/>
+          </a:effectRef>
+          <a:fontRef idx="minor">
+            <a:schemeClr val="lt1"/>
+          </a:fontRef>
+        </p:style>
+        <p:txBody>
+          <a:bodyPr rtlCol="0" anchor="ctr"/>
+          <a:lstStyle/>
+          <a:p>
+            <a:pPr algn="ctr"/>
+            <a:endParaRPr lang="en-US"/>
+          </a:p>
+        </p:txBody>
+      </p:sp>
+      <p:sp>
+        <p:nvSpPr>
+          <p:cNvPr id="57" name="Retângulo 56"/>
+          <p:cNvSpPr/>
+          <p:nvPr/>
+        </p:nvSpPr>
+        <p:spPr>
+          <a:xfrm>
+            <a:off x="304800" y="381000"/>
+            <a:ext cx="2438400" cy="1524000"/>
+          </a:xfrm>
+          <a:prstGeom prst="rect">
+            <a:avLst/>
+          </a:prstGeom>
+          <a:solidFill>
+            <a:schemeClr val="bg1"/>
+          </a:solidFill>
+          <a:ln w="6350">
+            <a:solidFill>
+              <a:schemeClr val="tx1"/>
+            </a:solidFill>
+          </a:ln>
+        </p:spPr>
+        <p:style>
+          <a:lnRef idx="2">
+            <a:schemeClr val="accent1">
+              <a:shade val="50000"/>
+            </a:schemeClr>
+          </a:lnRef>
+          <a:fillRef idx="1">
+            <a:schemeClr val="accent1"/>
+          </a:fillRef>
+          <a:effectRef idx="0">
+            <a:schemeClr val="accent1"/>
+          </a:effectRef>
+          <a:fontRef idx="minor">
+            <a:schemeClr val="lt1"/>
+          </a:fontRef>
+        </p:style>
+        <p:txBody>
+          <a:bodyPr rtlCol="0" anchor="ctr"/>
+          <a:lstStyle/>
+          <a:p>
+            <a:pPr algn="ctr"/>
+            <a:endParaRPr lang="en-US"/>
+          </a:p>
+        </p:txBody>
+      </p:sp>
+      <p:sp>
+        <p:nvSpPr>
+          <p:cNvPr id="41" name="Retângulo 40"/>
+          <p:cNvSpPr/>
+          <p:nvPr/>
+        </p:nvSpPr>
+        <p:spPr>
+          <a:xfrm>
+            <a:off x="3733800" y="1752600"/>
+            <a:ext cx="1752600" cy="3810000"/>
+          </a:xfrm>
+          <a:prstGeom prst="rect">
+            <a:avLst/>
+          </a:prstGeom>
+          <a:solidFill>
+            <a:schemeClr val="bg1">
+              <a:alpha val="0"/>
+            </a:schemeClr>
+          </a:solidFill>
+          <a:ln w="6350">
+            <a:solidFill>
+              <a:schemeClr val="tx1"/>
+            </a:solidFill>
+          </a:ln>
+        </p:spPr>
+        <p:style>
+          <a:lnRef idx="2">
+            <a:schemeClr val="accent1">
+              <a:shade val="50000"/>
+            </a:schemeClr>
+          </a:lnRef>
+          <a:fillRef idx="1">
+            <a:schemeClr val="accent1"/>
+          </a:fillRef>
+          <a:effectRef idx="0">
+            <a:schemeClr val="accent1"/>
+          </a:effectRef>
+          <a:fontRef idx="minor">
+            <a:schemeClr val="lt1"/>
+          </a:fontRef>
+        </p:style>
+        <p:txBody>
+          <a:bodyPr rtlCol="0" anchor="ctr"/>
+          <a:lstStyle/>
+          <a:p>
+            <a:pPr algn="ctr"/>
+            <a:endParaRPr lang="en-US"/>
+          </a:p>
+        </p:txBody>
+      </p:sp>
       <p:pic>
         <p:nvPicPr>
           <p:cNvPr id="16" name="Imagem 15" descr="excel.png"/>
@@ -3076,7 +3222,7 @@
         <p:spPr>
           <a:xfrm>
             <a:off x="8001000" y="1143000"/>
-            <a:ext cx="585810" cy="585810"/>
+            <a:ext cx="457200" cy="457200"/>
           </a:xfrm>
           <a:prstGeom prst="rect">
             <a:avLst/>
@@ -3092,15 +3238,15 @@
           <p:nvPr/>
         </p:nvPicPr>
         <p:blipFill>
-          <a:blip r:embed="rId3"/>
+          <a:blip r:embed="rId3" cstate="print"/>
           <a:stretch>
             <a:fillRect/>
           </a:stretch>
         </p:blipFill>
         <p:spPr>
           <a:xfrm>
-            <a:off x="1890576" y="1066800"/>
-            <a:ext cx="816243" cy="609600"/>
+            <a:off x="1905000" y="1143000"/>
+            <a:ext cx="612182" cy="457200"/>
           </a:xfrm>
           <a:prstGeom prst="rect">
             <a:avLst/>
@@ -3124,7 +3270,7 @@
         <p:spPr>
           <a:xfrm>
             <a:off x="1190364" y="1066800"/>
-            <a:ext cx="685800" cy="685800"/>
+            <a:ext cx="533400" cy="533400"/>
           </a:xfrm>
           <a:prstGeom prst="rect">
             <a:avLst/>
@@ -3147,8 +3293,8 @@
         </p:blipFill>
         <p:spPr>
           <a:xfrm>
-            <a:off x="381000" y="1066800"/>
-            <a:ext cx="818972" cy="720695"/>
+            <a:off x="381000" y="1066801"/>
+            <a:ext cx="685800" cy="603504"/>
           </a:xfrm>
           <a:prstGeom prst="rect">
             <a:avLst/>
@@ -3164,15 +3310,15 @@
           <p:nvPr/>
         </p:nvPicPr>
         <p:blipFill>
-          <a:blip r:embed="rId4" cstate="print"/>
+          <a:blip r:embed="rId6" cstate="print"/>
           <a:stretch>
             <a:fillRect/>
           </a:stretch>
         </p:blipFill>
         <p:spPr>
           <a:xfrm>
-            <a:off x="7206054" y="1066800"/>
-            <a:ext cx="685800" cy="685800"/>
+            <a:off x="7243116" y="1066800"/>
+            <a:ext cx="490146" cy="490146"/>
           </a:xfrm>
           <a:prstGeom prst="rect">
             <a:avLst/>
@@ -3188,15 +3334,15 @@
           <p:nvPr/>
         </p:nvPicPr>
         <p:blipFill>
-          <a:blip r:embed="rId6"/>
+          <a:blip r:embed="rId7"/>
           <a:stretch>
             <a:fillRect/>
           </a:stretch>
         </p:blipFill>
         <p:spPr>
           <a:xfrm>
-            <a:off x="6400800" y="1143000"/>
-            <a:ext cx="835252" cy="552450"/>
+            <a:off x="6503494" y="1143000"/>
+            <a:ext cx="576036" cy="381000"/>
           </a:xfrm>
           <a:prstGeom prst="rect">
             <a:avLst/>
@@ -3211,7 +3357,7 @@
         </p:nvCxnSpPr>
         <p:spPr>
           <a:xfrm>
-            <a:off x="1363362" y="2370426"/>
+            <a:off x="1132698" y="2370426"/>
             <a:ext cx="2286000" cy="1588"/>
           </a:xfrm>
           <a:prstGeom prst="straightConnector1">
@@ -3247,8 +3393,8 @@
         </p:nvCxnSpPr>
         <p:spPr>
           <a:xfrm rot="10800000">
-            <a:off x="5554362" y="2362188"/>
-            <a:ext cx="2058194" cy="1588"/>
+            <a:off x="5697266" y="2362188"/>
+            <a:ext cx="2286000" cy="1588"/>
           </a:xfrm>
           <a:prstGeom prst="straightConnector1">
             <a:avLst/>
@@ -3284,14 +3430,14 @@
           <p:nvPr/>
         </p:nvPicPr>
         <p:blipFill>
-          <a:blip r:embed="rId7"/>
+          <a:blip r:embed="rId8"/>
           <a:stretch>
             <a:fillRect/>
           </a:stretch>
         </p:blipFill>
         <p:spPr>
           <a:xfrm>
-            <a:off x="3892380" y="4057134"/>
+            <a:off x="3892380" y="4106562"/>
             <a:ext cx="1538602" cy="914400"/>
           </a:xfrm>
           <a:prstGeom prst="rect">
@@ -3307,8 +3453,8 @@
         </p:nvSpPr>
         <p:spPr>
           <a:xfrm>
-            <a:off x="4213656" y="3682308"/>
-            <a:ext cx="838200" cy="369332"/>
+            <a:off x="4038600" y="5078628"/>
+            <a:ext cx="1219200" cy="307777"/>
           </a:xfrm>
           <a:prstGeom prst="rect">
             <a:avLst/>
@@ -3322,10 +3468,10 @@
           <a:lstStyle/>
           <a:p>
             <a:r>
-              <a:rPr lang="en-US" dirty="0" smtClean="0"/>
-              <a:t>Recon</a:t>
-            </a:r>
-            <a:endParaRPr lang="en-US" dirty="0"/>
+              <a:rPr lang="en-US" sz="1400" dirty="0" smtClean="0"/>
+              <a:t>Match Engine</a:t>
+            </a:r>
+            <a:endParaRPr lang="en-US" sz="1400" dirty="0"/>
           </a:p>
         </p:txBody>
       </p:sp>
@@ -3337,8 +3483,8 @@
         </p:nvCxnSpPr>
         <p:spPr>
           <a:xfrm>
-            <a:off x="2362200" y="556056"/>
-            <a:ext cx="4495800" cy="1588"/>
+            <a:off x="2881194" y="556056"/>
+            <a:ext cx="3200400" cy="1588"/>
           </a:xfrm>
           <a:prstGeom prst="straightConnector1">
             <a:avLst/>
@@ -3373,8 +3519,8 @@
         </p:nvCxnSpPr>
         <p:spPr>
           <a:xfrm rot="10800000">
-            <a:off x="2362200" y="842322"/>
-            <a:ext cx="4420394" cy="1588"/>
+            <a:off x="2914122" y="858798"/>
+            <a:ext cx="3200400" cy="1588"/>
           </a:xfrm>
           <a:prstGeom prst="straightConnector1">
             <a:avLst/>
@@ -3433,61 +3579,13 @@
       </p:sp>
       <p:sp>
         <p:nvSpPr>
-          <p:cNvPr id="57" name="Retângulo 56"/>
-          <p:cNvSpPr/>
-          <p:nvPr/>
-        </p:nvSpPr>
-        <p:spPr>
-          <a:xfrm>
-            <a:off x="609600" y="381000"/>
-            <a:ext cx="1524000" cy="533400"/>
-          </a:xfrm>
-          <a:prstGeom prst="rect">
-            <a:avLst/>
-          </a:prstGeom>
-          <a:solidFill>
-            <a:schemeClr val="bg1"/>
-          </a:solidFill>
-          <a:ln>
-            <a:solidFill>
-              <a:schemeClr val="tx1"/>
-            </a:solidFill>
-          </a:ln>
-        </p:spPr>
-        <p:style>
-          <a:lnRef idx="2">
-            <a:schemeClr val="accent1">
-              <a:shade val="50000"/>
-            </a:schemeClr>
-          </a:lnRef>
-          <a:fillRef idx="1">
-            <a:schemeClr val="accent1"/>
-          </a:fillRef>
-          <a:effectRef idx="0">
-            <a:schemeClr val="accent1"/>
-          </a:effectRef>
-          <a:fontRef idx="minor">
-            <a:schemeClr val="lt1"/>
-          </a:fontRef>
-        </p:style>
-        <p:txBody>
-          <a:bodyPr rtlCol="0" anchor="ctr"/>
-          <a:lstStyle/>
-          <a:p>
-            <a:pPr algn="ctr"/>
-            <a:endParaRPr lang="en-US"/>
-          </a:p>
-        </p:txBody>
-      </p:sp>
-      <p:sp>
-        <p:nvSpPr>
           <p:cNvPr id="58" name="CaixaDeTexto 57"/>
           <p:cNvSpPr txBox="1"/>
           <p:nvPr/>
         </p:nvSpPr>
         <p:spPr>
           <a:xfrm>
-            <a:off x="762000" y="457200"/>
+            <a:off x="990600" y="457200"/>
             <a:ext cx="1219200" cy="369332"/>
           </a:xfrm>
           <a:prstGeom prst="rect">
@@ -3515,61 +3613,13 @@
       </p:sp>
       <p:sp>
         <p:nvSpPr>
-          <p:cNvPr id="59" name="Retângulo 58"/>
-          <p:cNvSpPr/>
-          <p:nvPr/>
-        </p:nvSpPr>
-        <p:spPr>
-          <a:xfrm>
-            <a:off x="7086600" y="381000"/>
-            <a:ext cx="1524000" cy="533400"/>
-          </a:xfrm>
-          <a:prstGeom prst="rect">
-            <a:avLst/>
-          </a:prstGeom>
-          <a:solidFill>
-            <a:schemeClr val="bg1"/>
-          </a:solidFill>
-          <a:ln>
-            <a:solidFill>
-              <a:schemeClr val="tx1"/>
-            </a:solidFill>
-          </a:ln>
-        </p:spPr>
-        <p:style>
-          <a:lnRef idx="2">
-            <a:schemeClr val="accent1">
-              <a:shade val="50000"/>
-            </a:schemeClr>
-          </a:lnRef>
-          <a:fillRef idx="1">
-            <a:schemeClr val="accent1"/>
-          </a:fillRef>
-          <a:effectRef idx="0">
-            <a:schemeClr val="accent1"/>
-          </a:effectRef>
-          <a:fontRef idx="minor">
-            <a:schemeClr val="lt1"/>
-          </a:fontRef>
-        </p:style>
-        <p:txBody>
-          <a:bodyPr rtlCol="0" anchor="ctr"/>
-          <a:lstStyle/>
-          <a:p>
-            <a:pPr algn="ctr"/>
-            <a:endParaRPr lang="en-US"/>
-          </a:p>
-        </p:txBody>
-      </p:sp>
-      <p:sp>
-        <p:nvSpPr>
           <p:cNvPr id="60" name="CaixaDeTexto 59"/>
           <p:cNvSpPr txBox="1"/>
           <p:nvPr/>
         </p:nvSpPr>
         <p:spPr>
           <a:xfrm>
-            <a:off x="7239000" y="457200"/>
+            <a:off x="6858000" y="457200"/>
             <a:ext cx="1219200" cy="369332"/>
           </a:xfrm>
           <a:prstGeom prst="rect">
@@ -3603,7 +3653,7 @@
         </p:nvCxnSpPr>
         <p:spPr>
           <a:xfrm rot="10800000">
-            <a:off x="2918256" y="4444308"/>
+            <a:off x="2440452" y="4444308"/>
             <a:ext cx="914400" cy="1588"/>
           </a:xfrm>
           <a:prstGeom prst="straightConnector1">
@@ -3639,7 +3689,7 @@
         </p:nvCxnSpPr>
         <p:spPr>
           <a:xfrm>
-            <a:off x="5509056" y="4444308"/>
+            <a:off x="5945670" y="4444308"/>
             <a:ext cx="838200" cy="1588"/>
           </a:xfrm>
           <a:prstGeom prst="straightConnector1">
@@ -3676,14 +3726,14 @@
           <p:nvPr/>
         </p:nvPicPr>
         <p:blipFill>
-          <a:blip r:embed="rId8"/>
+          <a:blip r:embed="rId9"/>
           <a:stretch>
             <a:fillRect/>
           </a:stretch>
         </p:blipFill>
         <p:spPr>
           <a:xfrm>
-            <a:off x="6499656" y="4139508"/>
+            <a:off x="6936270" y="4139508"/>
             <a:ext cx="685800" cy="685800"/>
           </a:xfrm>
           <a:prstGeom prst="rect">
@@ -3699,7 +3749,7 @@
         </p:nvSpPr>
         <p:spPr>
           <a:xfrm>
-            <a:off x="6575856" y="4901508"/>
+            <a:off x="7012470" y="4901508"/>
             <a:ext cx="1066800" cy="553998"/>
           </a:xfrm>
           <a:prstGeom prst="rect">
@@ -3715,24 +3765,14 @@
           <a:p>
             <a:r>
               <a:rPr lang="en-US" sz="1000" dirty="0" smtClean="0"/>
-              <a:t>5 </a:t>
-            </a:r>
+              <a:t>5 Batidos</a:t>
+            </a:r>
+          </a:p>
+          <a:p>
             <a:r>
               <a:rPr lang="en-US" sz="1000" dirty="0" smtClean="0"/>
-              <a:t>Batidos</a:t>
-            </a:r>
-            <a:endParaRPr lang="en-US" sz="1000" dirty="0" smtClean="0"/>
-          </a:p>
-          <a:p>
-            <a:r>
-              <a:rPr lang="en-US" sz="1000" dirty="0" smtClean="0"/>
-              <a:t>3 </a:t>
-            </a:r>
-            <a:r>
-              <a:rPr lang="en-US" sz="1000" dirty="0" smtClean="0"/>
-              <a:t>Divergentes</a:t>
-            </a:r>
-            <a:endParaRPr lang="en-US" sz="1000" dirty="0" smtClean="0"/>
+              <a:t>3 Divergentes</a:t>
+            </a:r>
           </a:p>
           <a:p>
             <a:r>
@@ -3752,14 +3792,14 @@
           <p:nvPr/>
         </p:nvPicPr>
         <p:blipFill>
-          <a:blip r:embed="rId9"/>
+          <a:blip r:embed="rId10"/>
           <a:stretch>
             <a:fillRect/>
           </a:stretch>
         </p:blipFill>
         <p:spPr>
           <a:xfrm>
-            <a:off x="2080056" y="4063308"/>
+            <a:off x="1602252" y="4063308"/>
             <a:ext cx="762000" cy="762000"/>
           </a:xfrm>
           <a:prstGeom prst="rect">
@@ -3775,7 +3815,7 @@
         </p:nvSpPr>
         <p:spPr>
           <a:xfrm>
-            <a:off x="1927656" y="4901508"/>
+            <a:off x="1449852" y="4901508"/>
             <a:ext cx="1066800" cy="707886"/>
           </a:xfrm>
           <a:prstGeom prst="rect">
@@ -3802,11 +3842,7 @@
           <a:p>
             <a:r>
               <a:rPr lang="en-US" sz="1000" dirty="0" smtClean="0"/>
-              <a:t>200,00 </a:t>
-            </a:r>
-            <a:r>
-              <a:rPr lang="en-US" sz="1000" dirty="0" smtClean="0"/>
-              <a:t>/ 199,00</a:t>
+              <a:t>200,00 / 199,00</a:t>
             </a:r>
           </a:p>
           <a:p>
@@ -3832,7 +3868,7 @@
         </p:nvCxnSpPr>
         <p:spPr>
           <a:xfrm rot="5400000">
-            <a:off x="1168746" y="2179938"/>
+            <a:off x="938082" y="2179938"/>
             <a:ext cx="381000" cy="1588"/>
           </a:xfrm>
           <a:prstGeom prst="line">
@@ -3867,7 +3903,7 @@
         </p:nvCxnSpPr>
         <p:spPr>
           <a:xfrm rot="5400000">
-            <a:off x="7422056" y="2170906"/>
+            <a:off x="7792766" y="2170906"/>
             <a:ext cx="381000" cy="1588"/>
           </a:xfrm>
           <a:prstGeom prst="line">
@@ -3903,15 +3939,15 @@
           <p:nvPr/>
         </p:nvPicPr>
         <p:blipFill>
-          <a:blip r:embed="rId10"/>
+          <a:blip r:embed="rId11"/>
           <a:stretch>
             <a:fillRect/>
           </a:stretch>
         </p:blipFill>
         <p:spPr>
           <a:xfrm>
-            <a:off x="3880020" y="1905000"/>
-            <a:ext cx="1396374" cy="1143000"/>
+            <a:off x="3937686" y="2133600"/>
+            <a:ext cx="1301580" cy="1065407"/>
           </a:xfrm>
           <a:prstGeom prst="rect">
             <a:avLst/>
@@ -3926,8 +3962,8 @@
         </p:nvSpPr>
         <p:spPr>
           <a:xfrm>
-            <a:off x="4238370" y="1600200"/>
-            <a:ext cx="838200" cy="369332"/>
+            <a:off x="4343400" y="3124200"/>
+            <a:ext cx="457200" cy="307777"/>
           </a:xfrm>
           <a:prstGeom prst="rect">
             <a:avLst/>
@@ -3941,10 +3977,10 @@
           <a:lstStyle/>
           <a:p>
             <a:r>
-              <a:rPr lang="en-US" dirty="0" smtClean="0"/>
+              <a:rPr lang="en-US" sz="1400" dirty="0" smtClean="0"/>
               <a:t>ETL</a:t>
             </a:r>
-            <a:endParaRPr lang="en-US" dirty="0"/>
+            <a:endParaRPr lang="en-US" sz="1400" dirty="0"/>
           </a:p>
         </p:txBody>
       </p:sp>
@@ -3956,7 +3992,7 @@
         </p:nvCxnSpPr>
         <p:spPr>
           <a:xfrm rot="5400000">
-            <a:off x="4153694" y="3342736"/>
+            <a:off x="4153694" y="3771112"/>
             <a:ext cx="533400" cy="1588"/>
           </a:xfrm>
           <a:prstGeom prst="straightConnector1">
@@ -3992,7 +4028,7 @@
         </p:nvCxnSpPr>
         <p:spPr>
           <a:xfrm rot="5400000">
-            <a:off x="4458494" y="3342736"/>
+            <a:off x="4458494" y="3771112"/>
             <a:ext cx="533400" cy="1588"/>
           </a:xfrm>
           <a:prstGeom prst="straightConnector1">
@@ -4029,14 +4065,14 @@
           <p:nvPr/>
         </p:nvPicPr>
         <p:blipFill>
-          <a:blip r:embed="rId11"/>
+          <a:blip r:embed="rId12"/>
           <a:stretch>
             <a:fillRect/>
           </a:stretch>
         </p:blipFill>
         <p:spPr>
           <a:xfrm>
-            <a:off x="2415744" y="2819400"/>
+            <a:off x="2086224" y="2819400"/>
             <a:ext cx="397565" cy="457200"/>
           </a:xfrm>
           <a:prstGeom prst="rect">
@@ -4052,7 +4088,7 @@
         </p:nvSpPr>
         <p:spPr>
           <a:xfrm>
-            <a:off x="2228334" y="3276600"/>
+            <a:off x="1898814" y="3276600"/>
             <a:ext cx="838200" cy="215444"/>
           </a:xfrm>
           <a:prstGeom prst="rect">
@@ -4091,14 +4127,14 @@
           <p:nvPr/>
         </p:nvPicPr>
         <p:blipFill>
-          <a:blip r:embed="rId11"/>
+          <a:blip r:embed="rId12"/>
           <a:stretch>
             <a:fillRect/>
           </a:stretch>
         </p:blipFill>
         <p:spPr>
           <a:xfrm>
-            <a:off x="1635210" y="2823516"/>
+            <a:off x="1305690" y="2823516"/>
             <a:ext cx="397565" cy="457200"/>
           </a:xfrm>
           <a:prstGeom prst="rect">
@@ -4114,7 +4150,7 @@
         </p:nvSpPr>
         <p:spPr>
           <a:xfrm>
-            <a:off x="1371600" y="3280716"/>
+            <a:off x="1042080" y="3280716"/>
             <a:ext cx="914400" cy="215444"/>
           </a:xfrm>
           <a:prstGeom prst="rect">
@@ -4152,7 +4188,7 @@
         </p:nvCxnSpPr>
         <p:spPr>
           <a:xfrm rot="10800000">
-            <a:off x="3150972" y="2988276"/>
+            <a:off x="2747310" y="2988276"/>
             <a:ext cx="838200" cy="1588"/>
           </a:xfrm>
           <a:prstGeom prst="straightConnector1">
@@ -4188,7 +4224,7 @@
         </p:nvCxnSpPr>
         <p:spPr>
           <a:xfrm rot="10800000">
-            <a:off x="3200400" y="3200400"/>
+            <a:off x="2796738" y="3200400"/>
             <a:ext cx="838200" cy="1588"/>
           </a:xfrm>
           <a:prstGeom prst="straightConnector1">
@@ -4231,14 +4267,14 @@
           <p:nvPr/>
         </p:nvPicPr>
         <p:blipFill>
-          <a:blip r:embed="rId11"/>
+          <a:blip r:embed="rId12"/>
           <a:stretch>
             <a:fillRect/>
           </a:stretch>
         </p:blipFill>
         <p:spPr>
           <a:xfrm>
-            <a:off x="838200" y="2819400"/>
+            <a:off x="508680" y="2819400"/>
             <a:ext cx="397565" cy="457200"/>
           </a:xfrm>
           <a:prstGeom prst="rect">
@@ -4254,7 +4290,7 @@
         </p:nvSpPr>
         <p:spPr>
           <a:xfrm>
-            <a:off x="574590" y="3276600"/>
+            <a:off x="245070" y="3276600"/>
             <a:ext cx="914400" cy="215444"/>
           </a:xfrm>
           <a:prstGeom prst="rect">
@@ -4277,6 +4313,36 @@
               <a:t> x Clearing</a:t>
             </a:r>
             <a:endParaRPr lang="en-US" sz="800" dirty="0"/>
+          </a:p>
+        </p:txBody>
+      </p:sp>
+      <p:sp>
+        <p:nvSpPr>
+          <p:cNvPr id="42" name="CaixaDeTexto 41"/>
+          <p:cNvSpPr txBox="1"/>
+          <p:nvPr/>
+        </p:nvSpPr>
+        <p:spPr>
+          <a:xfrm>
+            <a:off x="3962400" y="1777314"/>
+            <a:ext cx="1295400" cy="369332"/>
+          </a:xfrm>
+          <a:prstGeom prst="rect">
+            <a:avLst/>
+          </a:prstGeom>
+          <a:noFill/>
+        </p:spPr>
+        <p:txBody>
+          <a:bodyPr wrap="square" rtlCol="0">
+            <a:spAutoFit/>
+          </a:bodyPr>
+          <a:lstStyle/>
+          <a:p>
+            <a:r>
+              <a:rPr lang="en-US" dirty="0" smtClean="0"/>
+              <a:t>recon.exe</a:t>
+            </a:r>
+            <a:endParaRPr lang="en-US" dirty="0"/>
           </a:p>
         </p:txBody>
       </p:sp>

</xml_diff>